<commit_message>
phase3: generate calibrated planner review artifacts
</commit_message>
<xml_diff>
--- a/thesis-deck-system/artifacts/phase3/professor-shell-template.pptx
+++ b/thesis-deck-system/artifacts/phase3/professor-shell-template.pptx
@@ -403,8 +403,8 @@
         </p:nvSpPr>
         <p:spPr>
           <a:xfrm>
-            <a:off x="640080" y="1143000"/>
-            <a:ext cx="10835640" cy="4663440"/>
+            <a:off x="640080" y="1828800"/>
+            <a:ext cx="10835640" cy="3931920"/>
           </a:xfrm>
         </p:spPr>
         <p:txBody>
@@ -583,8 +583,8 @@
         </p:nvSpPr>
         <p:spPr>
           <a:xfrm>
-            <a:off x="640080" y="1143000"/>
-            <a:ext cx="10835640" cy="4663440"/>
+            <a:off x="640080" y="1828800"/>
+            <a:ext cx="10835640" cy="3931920"/>
           </a:xfrm>
         </p:spPr>
         <p:txBody>
@@ -763,8 +763,8 @@
         </p:nvSpPr>
         <p:spPr>
           <a:xfrm>
-            <a:off x="640080" y="1143000"/>
-            <a:ext cx="10835640" cy="4663440"/>
+            <a:off x="640080" y="1828800"/>
+            <a:ext cx="10835640" cy="3931920"/>
           </a:xfrm>
         </p:spPr>
         <p:txBody>
@@ -947,8 +947,8 @@
         </p:nvSpPr>
         <p:spPr>
           <a:xfrm>
-            <a:off x="640080" y="1143000"/>
-            <a:ext cx="10835640" cy="4663440"/>
+            <a:off x="640080" y="1828800"/>
+            <a:ext cx="10835640" cy="3931920"/>
           </a:xfrm>
         </p:spPr>
         <p:txBody>
@@ -1189,8 +1189,8 @@
         </p:nvSpPr>
         <p:spPr>
           <a:xfrm>
-            <a:off x="640080" y="1143000"/>
-            <a:ext cx="10835640" cy="4663440"/>
+            <a:off x="640080" y="1828800"/>
+            <a:ext cx="10835640" cy="3931920"/>
           </a:xfrm>
         </p:spPr>
         <p:txBody>
@@ -1274,8 +1274,8 @@
         </p:nvSpPr>
         <p:spPr>
           <a:xfrm>
-            <a:off x="640080" y="1143000"/>
-            <a:ext cx="10835640" cy="4663440"/>
+            <a:off x="640080" y="1828800"/>
+            <a:ext cx="10835640" cy="3931920"/>
           </a:xfrm>
         </p:spPr>
         <p:txBody>
@@ -1486,8 +1486,8 @@
         </p:nvSpPr>
         <p:spPr>
           <a:xfrm>
-            <a:off x="640080" y="1143000"/>
-            <a:ext cx="10835640" cy="4663440"/>
+            <a:off x="640080" y="1828800"/>
+            <a:ext cx="10835640" cy="3931920"/>
           </a:xfrm>
         </p:spPr>
         <p:txBody>
@@ -1551,8 +1551,8 @@
         </p:nvSpPr>
         <p:spPr>
           <a:xfrm>
-            <a:off x="640080" y="1143000"/>
-            <a:ext cx="10835640" cy="4663440"/>
+            <a:off x="640080" y="1828800"/>
+            <a:ext cx="10835640" cy="3931920"/>
           </a:xfrm>
         </p:spPr>
         <p:txBody>
@@ -1636,8 +1636,8 @@
         </p:nvSpPr>
         <p:spPr>
           <a:xfrm>
-            <a:off x="640080" y="1143000"/>
-            <a:ext cx="10835640" cy="4663440"/>
+            <a:off x="640080" y="1828800"/>
+            <a:ext cx="10835640" cy="3931920"/>
           </a:xfrm>
         </p:spPr>
         <p:txBody>
@@ -1701,8 +1701,8 @@
         </p:nvSpPr>
         <p:spPr>
           <a:xfrm>
-            <a:off x="640080" y="1143000"/>
-            <a:ext cx="10835640" cy="4663440"/>
+            <a:off x="640080" y="1828800"/>
+            <a:ext cx="10835640" cy="3931920"/>
           </a:xfrm>
         </p:spPr>
         <p:txBody>
@@ -2131,8 +2131,8 @@
         </p:nvSpPr>
         <p:spPr>
           <a:xfrm>
-            <a:off x="640080" y="1143000"/>
-            <a:ext cx="10835640" cy="4663440"/>
+            <a:off x="640080" y="1828800"/>
+            <a:ext cx="10835640" cy="3931920"/>
           </a:xfrm>
         </p:spPr>
         <p:txBody>
@@ -2216,8 +2216,8 @@
         </p:nvSpPr>
         <p:spPr>
           <a:xfrm>
-            <a:off x="640080" y="1143000"/>
-            <a:ext cx="10835640" cy="4663440"/>
+            <a:off x="640080" y="1828800"/>
+            <a:ext cx="10835640" cy="3931920"/>
           </a:xfrm>
         </p:spPr>
         <p:txBody>
@@ -2469,8 +2469,8 @@
         </p:nvSpPr>
         <p:spPr>
           <a:xfrm>
-            <a:off x="640080" y="1143000"/>
-            <a:ext cx="10835640" cy="4663440"/>
+            <a:off x="640080" y="1828800"/>
+            <a:ext cx="10835640" cy="3931920"/>
           </a:xfrm>
         </p:spPr>
         <p:txBody>

</xml_diff>